<commit_message>
Align sector one-pagers and decks with website; drop pricing and Tenderhouse
Co-Authored-By: Claude Sonnet 5.5 <noreply@anthropic.com>
Claude-Session: https://claude.ai/code/session_01L7EFGFT9ZTC3dXcHG7K4hg
</commit_message>
<xml_diff>
--- a/docs/flowgrid-os-customer-deck.pptx
+++ b/docs/flowgrid-os-customer-deck.pptx
@@ -10,7 +10,6 @@
     <p:sldId id="258" r:id="rId9"/>
     <p:sldId id="259" r:id="rId10"/>
     <p:sldId id="260" r:id="rId11"/>
-    <p:sldId id="261" r:id="rId12"/>
     <p:sldId id="262" r:id="rId13"/>
   </p:sldIdLst>
   <p:sldSz cx="12191695" cy="6858000" type="screen4x3"/>
@@ -3245,7 +3244,7 @@
                 </a:solidFill>
                 <a:latin typeface="Georgia"/>
               </a:rPr>
-              <a:t>AI workspace for UK small businesses</a:t>
+              <a:t>AI workspace for UK small organisations</a:t>
             </a:r>
           </a:p>
         </p:txBody>
@@ -3280,7 +3279,7 @@
                 </a:solidFill>
                 <a:latin typeface="Calibri"/>
               </a:rPr>
-              <a:t>One workspace. Your brand. Your data.</a:t>
+              <a:t>Turn what your organisation knows into work you can trust.</a:t>
             </a:r>
           </a:p>
         </p:txBody>
@@ -3453,7 +3452,7 @@
               </a:defRPr>
             </a:pPr>
             <a:r>
-              <a:t>• SMBs are buying AI in fragments — chat, documents, slides, research, each with its own login and bill.</a:t>
+              <a:t>• Small organisations run on scattered documents, repeated re-keying and blank-page reporting.</a:t>
             </a:r>
           </a:p>
           <a:p>
@@ -3472,7 +3471,7 @@
               </a:defRPr>
             </a:pPr>
             <a:r>
-              <a:t>• Closed models are expensive and often train on your data.</a:t>
+              <a:t>• Generic AI tools give uncited answers that are hard to check before they reach a funder or client.</a:t>
             </a:r>
           </a:p>
           <a:p>
@@ -3491,7 +3490,7 @@
               </a:defRPr>
             </a:pPr>
             <a:r>
-              <a:t>• Company knowledge sits in folders and spreadsheets, never where the work happens.</a:t>
+              <a:t>• What the organisation knows sits in folders and spreadsheets, never where the work happens.</a:t>
             </a:r>
           </a:p>
         </p:txBody>
@@ -3664,7 +3663,7 @@
               </a:defRPr>
             </a:pPr>
             <a:r>
-              <a:t>• A single branded workspace for every client: their logo, their accent, their documents.</a:t>
+              <a:t>• One workspace connects your source documents, confirmed facts and live projects.</a:t>
             </a:r>
           </a:p>
           <a:p>
@@ -3683,7 +3682,7 @@
               </a:defRPr>
             </a:pPr>
             <a:r>
-              <a:t>• Answers cite the source page, so staff can trust what the AI says.</a:t>
+              <a:t>• Answers cite the document and page, and say so plainly when the vault has nothing.</a:t>
             </a:r>
           </a:p>
           <a:p>
@@ -3702,7 +3701,7 @@
               </a:defRPr>
             </a:pPr>
             <a:r>
-              <a:t>• Every task is routed to the cheapest capable open-weight model — no closed-model lock-in.</a:t>
+              <a:t>• Confirm a fact once and every draft reuses it; projects carry stages, budgets and risks.</a:t>
             </a:r>
           </a:p>
           <a:p>
@@ -3721,7 +3720,7 @@
               </a:defRPr>
             </a:pPr>
             <a:r>
-              <a:t>• Usage caps and per-tenant budgets prevent surprise invoices.</a:t>
+              <a:t>• Branded PDF and editable PowerPoint outputs. You review everything; Flowgrid never sends on your behalf.</a:t>
             </a:r>
           </a:p>
         </p:txBody>
@@ -3894,7 +3893,7 @@
               </a:defRPr>
             </a:pPr>
             <a:r>
-              <a:t>• Branded AI chat with page-level citations</a:t>
+              <a:t>• Cited answers: every answer links to its document and page</a:t>
             </a:r>
           </a:p>
           <a:p>
@@ -3913,7 +3912,7 @@
               </a:defRPr>
             </a:pPr>
             <a:r>
-              <a:t>• Cited knowledge vault (PDF, Word, Excel, Markdown)</a:t>
+              <a:t>• Document vault (PDF, Word, Excel), searchable</a:t>
             </a:r>
           </a:p>
           <a:p>
@@ -3932,7 +3931,7 @@
               </a:defRPr>
             </a:pPr>
             <a:r>
-              <a:t>• Research mode with cited web sources</a:t>
+              <a:t>• Confirmed facts: review once, reuse in every draft</a:t>
             </a:r>
           </a:p>
           <a:p>
@@ -3951,7 +3950,7 @@
               </a:defRPr>
             </a:pPr>
             <a:r>
-              <a:t>• Native PowerPoint slide export</a:t>
+              <a:t>• Projects and plans with stages, budgets and risks</a:t>
             </a:r>
           </a:p>
         </p:txBody>
@@ -3993,7 +3992,7 @@
               </a:defRPr>
             </a:pPr>
             <a:r>
-              <a:t>• CRM contact book with CSV import</a:t>
+              <a:t>• Branded exports: PDF and editable PowerPoint</a:t>
             </a:r>
           </a:p>
           <a:p>
@@ -4012,7 +4011,7 @@
               </a:defRPr>
             </a:pPr>
             <a:r>
-              <a:t>• Project spine for stage-gated work</a:t>
+              <a:t>• Research mode with cited web sources</a:t>
             </a:r>
           </a:p>
           <a:p>
@@ -4031,7 +4030,7 @@
               </a:defRPr>
             </a:pPr>
             <a:r>
-              <a:t>• Email &amp; calendar sync (roadmap)</a:t>
+              <a:t>• Contact book with spreadsheet import</a:t>
             </a:r>
           </a:p>
           <a:p>
@@ -4050,7 +4049,26 @@
               </a:defRPr>
             </a:pPr>
             <a:r>
-              <a:t>• Meeting intelligence (roadmap)</a:t>
+              <a:t>• Usage and cost recorded on every AI call</a:t>
+            </a:r>
+          </a:p>
+          <a:p>
+            <a:pPr>
+              <a:lnSpc>
+                <a:spcPct val="120000"/>
+              </a:lnSpc>
+              <a:spcAft>
+                <a:spcPts val="1000"/>
+              </a:spcAft>
+              <a:defRPr sz="1900">
+                <a:solidFill>
+                  <a:srgbClr val="2D2A26"/>
+                </a:solidFill>
+                <a:latin typeface="Calibri"/>
+              </a:defRPr>
+            </a:pPr>
+            <a:r>
+              <a:t>• Coming: email &amp; calendar sync, meeting intelligence</a:t>
             </a:r>
           </a:p>
         </p:txBody>
@@ -4223,7 +4241,7 @@
               </a:defRPr>
             </a:pPr>
             <a:r>
-              <a:t>• Tenant isolation enforced by Postgres row-level security.</a:t>
+              <a:t>• Your workspace is isolated from every other customer at the database level, not only by application code.</a:t>
             </a:r>
           </a:p>
           <a:p>
@@ -4242,7 +4260,7 @@
               </a:defRPr>
             </a:pPr>
             <a:r>
-              <a:t>• Zero-data-retention US/EU hosts by default; nothing trains on your files.</a:t>
+              <a:t>• UK-held data. Zero-data-retention hosting by default; your documents are not used to train anyone’s models.</a:t>
             </a:r>
           </a:p>
           <a:p>
@@ -4261,7 +4279,7 @@
               </a:defRPr>
             </a:pPr>
             <a:r>
-              <a:t>• Soft caps nudge, hard caps protect; full audit logs.</a:t>
+              <a:t>• UK GDPR, with a Data Processing Agreement as part of your terms, plus standard-format export and agreed return and deletion.</a:t>
             </a:r>
           </a:p>
           <a:p>
@@ -4280,7 +4298,7 @@
               </a:defRPr>
             </a:pPr>
             <a:r>
-              <a:t>• MIT/Apache stack only — no hidden licensing overhang.</a:t>
+              <a:t>• Every AI call is recorded with usage and cost, and spending limits keep invoices predictable.</a:t>
             </a:r>
           </a:p>
         </p:txBody>
@@ -4288,941 +4306,6 @@
       <p:sp>
         <p:nvSpPr>
           <p:cNvPr id="5" name="TextBox 4"/>
-          <p:cNvSpPr txBox="1"/>
-          <p:nvPr/>
-        </p:nvSpPr>
-        <p:spPr>
-          <a:xfrm>
-            <a:off x="548640" y="6537960"/>
-            <a:ext cx="11094415" cy="228600"/>
-          </a:xfrm>
-          <a:prstGeom prst="rect">
-            <a:avLst/>
-          </a:prstGeom>
-          <a:noFill/>
-        </p:spPr>
-        <p:txBody>
-          <a:bodyPr wrap="square">
-            <a:spAutoFit/>
-          </a:bodyPr>
-          <a:lstStyle/>
-          <a:p>
-            <a:pPr algn="r"/>
-            <a:r>
-              <a:rPr sz="1000" b="0">
-                <a:solidFill>
-                  <a:srgbClr val="5B5752"/>
-                </a:solidFill>
-                <a:latin typeface="Calibri"/>
-              </a:rPr>
-              <a:t>flowgridos.co.uk</a:t>
-            </a:r>
-          </a:p>
-        </p:txBody>
-      </p:sp>
-    </p:spTree>
-  </p:cSld>
-  <p:clrMapOvr>
-    <a:masterClrMapping/>
-  </p:clrMapOvr>
-</p:sld>
-</file>
-
-<file path=ppt/slides/slide6.xml><?xml version="1.0" encoding="utf-8"?>
-<p:sld xmlns:a="http://schemas.openxmlformats.org/drawingml/2006/main" xmlns:p="http://schemas.openxmlformats.org/presentationml/2006/main" xmlns:r="http://schemas.openxmlformats.org/officeDocument/2006/relationships">
-  <p:cSld>
-    <p:spTree>
-      <p:nvGrpSpPr>
-        <p:cNvPr id="1" name=""/>
-        <p:cNvGrpSpPr/>
-        <p:nvPr/>
-      </p:nvGrpSpPr>
-      <p:grpSpPr/>
-      <p:sp>
-        <p:nvSpPr>
-          <p:cNvPr id="2" name="Rectangle 1"/>
-          <p:cNvSpPr/>
-          <p:nvPr/>
-        </p:nvSpPr>
-        <p:spPr>
-          <a:xfrm>
-            <a:off x="0" y="0"/>
-            <a:ext cx="12191695" cy="1005840"/>
-          </a:xfrm>
-          <a:prstGeom prst="rect">
-            <a:avLst/>
-          </a:prstGeom>
-          <a:solidFill>
-            <a:srgbClr val="B14E2E"/>
-          </a:solidFill>
-          <a:ln>
-            <a:noFill/>
-          </a:ln>
-        </p:spPr>
-        <p:style>
-          <a:lnRef idx="1">
-            <a:schemeClr val="accent1"/>
-          </a:lnRef>
-          <a:fillRef idx="3">
-            <a:schemeClr val="accent1"/>
-          </a:fillRef>
-          <a:effectRef idx="2">
-            <a:schemeClr val="accent1"/>
-          </a:effectRef>
-          <a:fontRef idx="minor">
-            <a:schemeClr val="lt1"/>
-          </a:fontRef>
-        </p:style>
-        <p:txBody>
-          <a:bodyPr rtlCol="0" anchor="ctr"/>
-          <a:lstStyle/>
-          <a:p>
-            <a:pPr algn="ctr"/>
-          </a:p>
-        </p:txBody>
-      </p:sp>
-      <p:sp>
-        <p:nvSpPr>
-          <p:cNvPr id="3" name="TextBox 2"/>
-          <p:cNvSpPr txBox="1"/>
-          <p:nvPr/>
-        </p:nvSpPr>
-        <p:spPr>
-          <a:xfrm>
-            <a:off x="548640" y="201168"/>
-            <a:ext cx="11094415" cy="731520"/>
-          </a:xfrm>
-          <a:prstGeom prst="rect">
-            <a:avLst/>
-          </a:prstGeom>
-          <a:noFill/>
-        </p:spPr>
-        <p:txBody>
-          <a:bodyPr wrap="square">
-            <a:spAutoFit/>
-          </a:bodyPr>
-          <a:lstStyle/>
-          <a:p>
-            <a:pPr algn="l"/>
-            <a:r>
-              <a:rPr sz="3400" b="1">
-                <a:solidFill>
-                  <a:srgbClr val="FFFFFF"/>
-                </a:solidFill>
-                <a:latin typeface="Georgia"/>
-              </a:rPr>
-              <a:t>Simple, per-seat pricing</a:t>
-            </a:r>
-          </a:p>
-        </p:txBody>
-      </p:sp>
-      <p:sp>
-        <p:nvSpPr>
-          <p:cNvPr id="4" name="Rounded Rectangle 3"/>
-          <p:cNvSpPr/>
-          <p:nvPr/>
-        </p:nvSpPr>
-        <p:spPr>
-          <a:xfrm>
-            <a:off x="548640" y="1371600"/>
-            <a:ext cx="3515258" cy="4389120"/>
-          </a:xfrm>
-          <a:prstGeom prst="roundRect">
-            <a:avLst/>
-          </a:prstGeom>
-          <a:solidFill>
-            <a:srgbClr val="F6F2ED"/>
-          </a:solidFill>
-          <a:ln w="25400">
-            <a:solidFill>
-              <a:srgbClr val="B14E2E"/>
-            </a:solidFill>
-          </a:ln>
-        </p:spPr>
-        <p:style>
-          <a:lnRef idx="1">
-            <a:schemeClr val="accent1"/>
-          </a:lnRef>
-          <a:fillRef idx="3">
-            <a:schemeClr val="accent1"/>
-          </a:fillRef>
-          <a:effectRef idx="2">
-            <a:schemeClr val="accent1"/>
-          </a:effectRef>
-          <a:fontRef idx="minor">
-            <a:schemeClr val="lt1"/>
-          </a:fontRef>
-        </p:style>
-        <p:txBody>
-          <a:bodyPr rtlCol="0" anchor="ctr"/>
-          <a:lstStyle/>
-          <a:p>
-            <a:pPr algn="ctr"/>
-          </a:p>
-        </p:txBody>
-      </p:sp>
-      <p:sp>
-        <p:nvSpPr>
-          <p:cNvPr id="5" name="TextBox 4"/>
-          <p:cNvSpPr txBox="1"/>
-          <p:nvPr/>
-        </p:nvSpPr>
-        <p:spPr>
-          <a:xfrm>
-            <a:off x="685800" y="1508760"/>
-            <a:ext cx="3240938" cy="457200"/>
-          </a:xfrm>
-          <a:prstGeom prst="rect">
-            <a:avLst/>
-          </a:prstGeom>
-          <a:noFill/>
-        </p:spPr>
-        <p:txBody>
-          <a:bodyPr wrap="square">
-            <a:spAutoFit/>
-          </a:bodyPr>
-          <a:lstStyle/>
-          <a:p>
-            <a:pPr algn="ctr"/>
-            <a:r>
-              <a:rPr sz="2200" b="1">
-                <a:solidFill>
-                  <a:srgbClr val="B14E2E"/>
-                </a:solidFill>
-                <a:latin typeface="Georgia"/>
-              </a:rPr>
-              <a:t>Core</a:t>
-            </a:r>
-          </a:p>
-        </p:txBody>
-      </p:sp>
-      <p:sp>
-        <p:nvSpPr>
-          <p:cNvPr id="6" name="TextBox 5"/>
-          <p:cNvSpPr txBox="1"/>
-          <p:nvPr/>
-        </p:nvSpPr>
-        <p:spPr>
-          <a:xfrm>
-            <a:off x="685800" y="2011680"/>
-            <a:ext cx="3240938" cy="548640"/>
-          </a:xfrm>
-          <a:prstGeom prst="rect">
-            <a:avLst/>
-          </a:prstGeom>
-          <a:noFill/>
-        </p:spPr>
-        <p:txBody>
-          <a:bodyPr wrap="square">
-            <a:spAutoFit/>
-          </a:bodyPr>
-          <a:lstStyle/>
-          <a:p>
-            <a:pPr algn="ctr"/>
-            <a:r>
-              <a:rPr sz="3200" b="1">
-                <a:solidFill>
-                  <a:srgbClr val="B14E2E"/>
-                </a:solidFill>
-                <a:latin typeface="Calibri"/>
-              </a:rPr>
-              <a:t>£29</a:t>
-            </a:r>
-          </a:p>
-        </p:txBody>
-      </p:sp>
-      <p:sp>
-        <p:nvSpPr>
-          <p:cNvPr id="7" name="TextBox 6"/>
-          <p:cNvSpPr txBox="1"/>
-          <p:nvPr/>
-        </p:nvSpPr>
-        <p:spPr>
-          <a:xfrm>
-            <a:off x="685800" y="2514600"/>
-            <a:ext cx="3240938" cy="365760"/>
-          </a:xfrm>
-          <a:prstGeom prst="rect">
-            <a:avLst/>
-          </a:prstGeom>
-          <a:noFill/>
-        </p:spPr>
-        <p:txBody>
-          <a:bodyPr wrap="square">
-            <a:spAutoFit/>
-          </a:bodyPr>
-          <a:lstStyle/>
-          <a:p>
-            <a:pPr algn="ctr"/>
-            <a:r>
-              <a:rPr sz="1200" b="0">
-                <a:solidFill>
-                  <a:srgbClr val="2D2A26"/>
-                </a:solidFill>
-                <a:latin typeface="Calibri"/>
-              </a:rPr>
-              <a:t>/seat/mo · min 3</a:t>
-            </a:r>
-          </a:p>
-        </p:txBody>
-      </p:sp>
-      <p:sp>
-        <p:nvSpPr>
-          <p:cNvPr id="8" name="TextBox 7"/>
-          <p:cNvSpPr txBox="1"/>
-          <p:nvPr/>
-        </p:nvSpPr>
-        <p:spPr>
-          <a:xfrm>
-            <a:off x="731520" y="2971800"/>
-            <a:ext cx="3149498" cy="2560320"/>
-          </a:xfrm>
-          <a:prstGeom prst="rect">
-            <a:avLst/>
-          </a:prstGeom>
-          <a:noFill/>
-        </p:spPr>
-        <p:txBody>
-          <a:bodyPr wrap="square" anchor="t">
-            <a:spAutoFit/>
-          </a:bodyPr>
-          <a:lstStyle/>
-          <a:p>
-            <a:pPr>
-              <a:lnSpc>
-                <a:spcPct val="120000"/>
-              </a:lnSpc>
-              <a:spcAft>
-                <a:spcPts val="1000"/>
-              </a:spcAft>
-              <a:defRPr sz="1400">
-                <a:solidFill>
-                  <a:srgbClr val="2D2A26"/>
-                </a:solidFill>
-                <a:latin typeface="Calibri"/>
-              </a:defRPr>
-            </a:pPr>
-            <a:r>
-              <a:t>• Workspace &amp; chat</a:t>
-            </a:r>
-          </a:p>
-          <a:p>
-            <a:pPr>
-              <a:lnSpc>
-                <a:spcPct val="120000"/>
-              </a:lnSpc>
-              <a:spcAft>
-                <a:spcPts val="1000"/>
-              </a:spcAft>
-              <a:defRPr sz="1400">
-                <a:solidFill>
-                  <a:srgbClr val="2D2A26"/>
-                </a:solidFill>
-                <a:latin typeface="Calibri"/>
-              </a:defRPr>
-            </a:pPr>
-            <a:r>
-              <a:t>• Vault &amp; citations</a:t>
-            </a:r>
-          </a:p>
-          <a:p>
-            <a:pPr>
-              <a:lnSpc>
-                <a:spcPct val="120000"/>
-              </a:lnSpc>
-              <a:spcAft>
-                <a:spcPts val="1000"/>
-              </a:spcAft>
-              <a:defRPr sz="1400">
-                <a:solidFill>
-                  <a:srgbClr val="2D2A26"/>
-                </a:solidFill>
-                <a:latin typeface="Calibri"/>
-              </a:defRPr>
-            </a:pPr>
-            <a:r>
-              <a:t>• Research &amp; slides</a:t>
-            </a:r>
-          </a:p>
-          <a:p>
-            <a:pPr>
-              <a:lnSpc>
-                <a:spcPct val="120000"/>
-              </a:lnSpc>
-              <a:spcAft>
-                <a:spcPts val="1000"/>
-              </a:spcAft>
-              <a:defRPr sz="1400">
-                <a:solidFill>
-                  <a:srgbClr val="2D2A26"/>
-                </a:solidFill>
-                <a:latin typeface="Calibri"/>
-              </a:defRPr>
-            </a:pPr>
-            <a:r>
-              <a:t>• CRM contacts</a:t>
-            </a:r>
-          </a:p>
-          <a:p>
-            <a:pPr>
-              <a:lnSpc>
-                <a:spcPct val="120000"/>
-              </a:lnSpc>
-              <a:spcAft>
-                <a:spcPts val="1000"/>
-              </a:spcAft>
-              <a:defRPr sz="1400">
-                <a:solidFill>
-                  <a:srgbClr val="2D2A26"/>
-                </a:solidFill>
-                <a:latin typeface="Calibri"/>
-              </a:defRPr>
-            </a:pPr>
-            <a:r>
-              <a:t>• Standard support</a:t>
-            </a:r>
-          </a:p>
-        </p:txBody>
-      </p:sp>
-      <p:sp>
-        <p:nvSpPr>
-          <p:cNvPr id="9" name="Rounded Rectangle 8"/>
-          <p:cNvSpPr/>
-          <p:nvPr/>
-        </p:nvSpPr>
-        <p:spPr>
-          <a:xfrm>
-            <a:off x="4338218" y="1371600"/>
-            <a:ext cx="3515258" cy="4389120"/>
-          </a:xfrm>
-          <a:prstGeom prst="roundRect">
-            <a:avLst/>
-          </a:prstGeom>
-          <a:solidFill>
-            <a:srgbClr val="B14E2E"/>
-          </a:solidFill>
-          <a:ln w="25400">
-            <a:solidFill>
-              <a:srgbClr val="B14E2E"/>
-            </a:solidFill>
-          </a:ln>
-        </p:spPr>
-        <p:style>
-          <a:lnRef idx="1">
-            <a:schemeClr val="accent1"/>
-          </a:lnRef>
-          <a:fillRef idx="3">
-            <a:schemeClr val="accent1"/>
-          </a:fillRef>
-          <a:effectRef idx="2">
-            <a:schemeClr val="accent1"/>
-          </a:effectRef>
-          <a:fontRef idx="minor">
-            <a:schemeClr val="lt1"/>
-          </a:fontRef>
-        </p:style>
-        <p:txBody>
-          <a:bodyPr rtlCol="0" anchor="ctr"/>
-          <a:lstStyle/>
-          <a:p>
-            <a:pPr algn="ctr"/>
-          </a:p>
-        </p:txBody>
-      </p:sp>
-      <p:sp>
-        <p:nvSpPr>
-          <p:cNvPr id="10" name="TextBox 9"/>
-          <p:cNvSpPr txBox="1"/>
-          <p:nvPr/>
-        </p:nvSpPr>
-        <p:spPr>
-          <a:xfrm>
-            <a:off x="4475378" y="1508760"/>
-            <a:ext cx="3240938" cy="457200"/>
-          </a:xfrm>
-          <a:prstGeom prst="rect">
-            <a:avLst/>
-          </a:prstGeom>
-          <a:noFill/>
-        </p:spPr>
-        <p:txBody>
-          <a:bodyPr wrap="square">
-            <a:spAutoFit/>
-          </a:bodyPr>
-          <a:lstStyle/>
-          <a:p>
-            <a:pPr algn="ctr"/>
-            <a:r>
-              <a:rPr sz="2200" b="1">
-                <a:solidFill>
-                  <a:srgbClr val="FFFFFF"/>
-                </a:solidFill>
-                <a:latin typeface="Georgia"/>
-              </a:rPr>
-              <a:t>Pro</a:t>
-            </a:r>
-          </a:p>
-        </p:txBody>
-      </p:sp>
-      <p:sp>
-        <p:nvSpPr>
-          <p:cNvPr id="11" name="TextBox 10"/>
-          <p:cNvSpPr txBox="1"/>
-          <p:nvPr/>
-        </p:nvSpPr>
-        <p:spPr>
-          <a:xfrm>
-            <a:off x="4475378" y="2011680"/>
-            <a:ext cx="3240938" cy="548640"/>
-          </a:xfrm>
-          <a:prstGeom prst="rect">
-            <a:avLst/>
-          </a:prstGeom>
-          <a:noFill/>
-        </p:spPr>
-        <p:txBody>
-          <a:bodyPr wrap="square">
-            <a:spAutoFit/>
-          </a:bodyPr>
-          <a:lstStyle/>
-          <a:p>
-            <a:pPr algn="ctr"/>
-            <a:r>
-              <a:rPr sz="3200" b="1">
-                <a:solidFill>
-                  <a:srgbClr val="FFFFFF"/>
-                </a:solidFill>
-                <a:latin typeface="Calibri"/>
-              </a:rPr>
-              <a:t>£49</a:t>
-            </a:r>
-          </a:p>
-        </p:txBody>
-      </p:sp>
-      <p:sp>
-        <p:nvSpPr>
-          <p:cNvPr id="12" name="TextBox 11"/>
-          <p:cNvSpPr txBox="1"/>
-          <p:nvPr/>
-        </p:nvSpPr>
-        <p:spPr>
-          <a:xfrm>
-            <a:off x="4475378" y="2514600"/>
-            <a:ext cx="3240938" cy="365760"/>
-          </a:xfrm>
-          <a:prstGeom prst="rect">
-            <a:avLst/>
-          </a:prstGeom>
-          <a:noFill/>
-        </p:spPr>
-        <p:txBody>
-          <a:bodyPr wrap="square">
-            <a:spAutoFit/>
-          </a:bodyPr>
-          <a:lstStyle/>
-          <a:p>
-            <a:pPr algn="ctr"/>
-            <a:r>
-              <a:rPr sz="1200" b="0">
-                <a:solidFill>
-                  <a:srgbClr val="FFFFFF"/>
-                </a:solidFill>
-                <a:latin typeface="Calibri"/>
-              </a:rPr>
-              <a:t>/seat/mo</a:t>
-            </a:r>
-          </a:p>
-        </p:txBody>
-      </p:sp>
-      <p:sp>
-        <p:nvSpPr>
-          <p:cNvPr id="13" name="TextBox 12"/>
-          <p:cNvSpPr txBox="1"/>
-          <p:nvPr/>
-        </p:nvSpPr>
-        <p:spPr>
-          <a:xfrm>
-            <a:off x="4521098" y="2971800"/>
-            <a:ext cx="3149498" cy="2560320"/>
-          </a:xfrm>
-          <a:prstGeom prst="rect">
-            <a:avLst/>
-          </a:prstGeom>
-          <a:noFill/>
-        </p:spPr>
-        <p:txBody>
-          <a:bodyPr wrap="square" anchor="t">
-            <a:spAutoFit/>
-          </a:bodyPr>
-          <a:lstStyle/>
-          <a:p>
-            <a:pPr>
-              <a:lnSpc>
-                <a:spcPct val="120000"/>
-              </a:lnSpc>
-              <a:spcAft>
-                <a:spcPts val="1000"/>
-              </a:spcAft>
-              <a:defRPr sz="1400">
-                <a:solidFill>
-                  <a:srgbClr val="FFFFFF"/>
-                </a:solidFill>
-                <a:latin typeface="Calibri"/>
-              </a:defRPr>
-            </a:pPr>
-            <a:r>
-              <a:t>• Everything in Core</a:t>
-            </a:r>
-          </a:p>
-          <a:p>
-            <a:pPr>
-              <a:lnSpc>
-                <a:spcPct val="120000"/>
-              </a:lnSpc>
-              <a:spcAft>
-                <a:spcPts val="1000"/>
-              </a:spcAft>
-              <a:defRPr sz="1400">
-                <a:solidFill>
-                  <a:srgbClr val="FFFFFF"/>
-                </a:solidFill>
-                <a:latin typeface="Calibri"/>
-              </a:defRPr>
-            </a:pPr>
-            <a:r>
-              <a:t>• Premium reasoning</a:t>
-            </a:r>
-          </a:p>
-          <a:p>
-            <a:pPr>
-              <a:lnSpc>
-                <a:spcPct val="120000"/>
-              </a:lnSpc>
-              <a:spcAft>
-                <a:spcPts val="1000"/>
-              </a:spcAft>
-              <a:defRPr sz="1400">
-                <a:solidFill>
-                  <a:srgbClr val="FFFFFF"/>
-                </a:solidFill>
-                <a:latin typeface="Calibri"/>
-              </a:defRPr>
-            </a:pPr>
-            <a:r>
-              <a:t>• Deep research</a:t>
-            </a:r>
-          </a:p>
-          <a:p>
-            <a:pPr>
-              <a:lnSpc>
-                <a:spcPct val="120000"/>
-              </a:lnSpc>
-              <a:spcAft>
-                <a:spcPts val="1000"/>
-              </a:spcAft>
-              <a:defRPr sz="1400">
-                <a:solidFill>
-                  <a:srgbClr val="FFFFFF"/>
-                </a:solidFill>
-                <a:latin typeface="Calibri"/>
-              </a:defRPr>
-            </a:pPr>
-            <a:r>
-              <a:t>• Advanced reporting</a:t>
-            </a:r>
-          </a:p>
-          <a:p>
-            <a:pPr>
-              <a:lnSpc>
-                <a:spcPct val="120000"/>
-              </a:lnSpc>
-              <a:spcAft>
-                <a:spcPts val="1000"/>
-              </a:spcAft>
-              <a:defRPr sz="1400">
-                <a:solidFill>
-                  <a:srgbClr val="FFFFFF"/>
-                </a:solidFill>
-                <a:latin typeface="Calibri"/>
-              </a:defRPr>
-            </a:pPr>
-            <a:r>
-              <a:t>• Priority support</a:t>
-            </a:r>
-          </a:p>
-        </p:txBody>
-      </p:sp>
-      <p:sp>
-        <p:nvSpPr>
-          <p:cNvPr id="14" name="Rounded Rectangle 13"/>
-          <p:cNvSpPr/>
-          <p:nvPr/>
-        </p:nvSpPr>
-        <p:spPr>
-          <a:xfrm>
-            <a:off x="8127796" y="1371600"/>
-            <a:ext cx="3515258" cy="4389120"/>
-          </a:xfrm>
-          <a:prstGeom prst="roundRect">
-            <a:avLst/>
-          </a:prstGeom>
-          <a:solidFill>
-            <a:srgbClr val="F6F2ED"/>
-          </a:solidFill>
-          <a:ln w="25400">
-            <a:solidFill>
-              <a:srgbClr val="B14E2E"/>
-            </a:solidFill>
-          </a:ln>
-        </p:spPr>
-        <p:style>
-          <a:lnRef idx="1">
-            <a:schemeClr val="accent1"/>
-          </a:lnRef>
-          <a:fillRef idx="3">
-            <a:schemeClr val="accent1"/>
-          </a:fillRef>
-          <a:effectRef idx="2">
-            <a:schemeClr val="accent1"/>
-          </a:effectRef>
-          <a:fontRef idx="minor">
-            <a:schemeClr val="lt1"/>
-          </a:fontRef>
-        </p:style>
-        <p:txBody>
-          <a:bodyPr rtlCol="0" anchor="ctr"/>
-          <a:lstStyle/>
-          <a:p>
-            <a:pPr algn="ctr"/>
-          </a:p>
-        </p:txBody>
-      </p:sp>
-      <p:sp>
-        <p:nvSpPr>
-          <p:cNvPr id="15" name="TextBox 14"/>
-          <p:cNvSpPr txBox="1"/>
-          <p:nvPr/>
-        </p:nvSpPr>
-        <p:spPr>
-          <a:xfrm>
-            <a:off x="8264956" y="1508760"/>
-            <a:ext cx="3240938" cy="457200"/>
-          </a:xfrm>
-          <a:prstGeom prst="rect">
-            <a:avLst/>
-          </a:prstGeom>
-          <a:noFill/>
-        </p:spPr>
-        <p:txBody>
-          <a:bodyPr wrap="square">
-            <a:spAutoFit/>
-          </a:bodyPr>
-          <a:lstStyle/>
-          <a:p>
-            <a:pPr algn="ctr"/>
-            <a:r>
-              <a:rPr sz="2200" b="1">
-                <a:solidFill>
-                  <a:srgbClr val="B14E2E"/>
-                </a:solidFill>
-                <a:latin typeface="Georgia"/>
-              </a:rPr>
-              <a:t>Managed</a:t>
-            </a:r>
-          </a:p>
-        </p:txBody>
-      </p:sp>
-      <p:sp>
-        <p:nvSpPr>
-          <p:cNvPr id="16" name="TextBox 15"/>
-          <p:cNvSpPr txBox="1"/>
-          <p:nvPr/>
-        </p:nvSpPr>
-        <p:spPr>
-          <a:xfrm>
-            <a:off x="8264956" y="2011680"/>
-            <a:ext cx="3240938" cy="548640"/>
-          </a:xfrm>
-          <a:prstGeom prst="rect">
-            <a:avLst/>
-          </a:prstGeom>
-          <a:noFill/>
-        </p:spPr>
-        <p:txBody>
-          <a:bodyPr wrap="square">
-            <a:spAutoFit/>
-          </a:bodyPr>
-          <a:lstStyle/>
-          <a:p>
-            <a:pPr algn="ctr"/>
-            <a:r>
-              <a:rPr sz="3200" b="1">
-                <a:solidFill>
-                  <a:srgbClr val="B14E2E"/>
-                </a:solidFill>
-                <a:latin typeface="Calibri"/>
-              </a:rPr>
-              <a:t>£799</a:t>
-            </a:r>
-          </a:p>
-        </p:txBody>
-      </p:sp>
-      <p:sp>
-        <p:nvSpPr>
-          <p:cNvPr id="17" name="TextBox 16"/>
-          <p:cNvSpPr txBox="1"/>
-          <p:nvPr/>
-        </p:nvSpPr>
-        <p:spPr>
-          <a:xfrm>
-            <a:off x="8264956" y="2514600"/>
-            <a:ext cx="3240938" cy="365760"/>
-          </a:xfrm>
-          <a:prstGeom prst="rect">
-            <a:avLst/>
-          </a:prstGeom>
-          <a:noFill/>
-        </p:spPr>
-        <p:txBody>
-          <a:bodyPr wrap="square">
-            <a:spAutoFit/>
-          </a:bodyPr>
-          <a:lstStyle/>
-          <a:p>
-            <a:pPr algn="ctr"/>
-            <a:r>
-              <a:rPr sz="1200" b="0">
-                <a:solidFill>
-                  <a:srgbClr val="2D2A26"/>
-                </a:solidFill>
-                <a:latin typeface="Calibri"/>
-              </a:rPr>
-              <a:t>/mo + £1,500 onboarding</a:t>
-            </a:r>
-          </a:p>
-        </p:txBody>
-      </p:sp>
-      <p:sp>
-        <p:nvSpPr>
-          <p:cNvPr id="18" name="TextBox 17"/>
-          <p:cNvSpPr txBox="1"/>
-          <p:nvPr/>
-        </p:nvSpPr>
-        <p:spPr>
-          <a:xfrm>
-            <a:off x="8310676" y="2971800"/>
-            <a:ext cx="3149498" cy="2560320"/>
-          </a:xfrm>
-          <a:prstGeom prst="rect">
-            <a:avLst/>
-          </a:prstGeom>
-          <a:noFill/>
-        </p:spPr>
-        <p:txBody>
-          <a:bodyPr wrap="square" anchor="t">
-            <a:spAutoFit/>
-          </a:bodyPr>
-          <a:lstStyle/>
-          <a:p>
-            <a:pPr>
-              <a:lnSpc>
-                <a:spcPct val="120000"/>
-              </a:lnSpc>
-              <a:spcAft>
-                <a:spcPts val="1000"/>
-              </a:spcAft>
-              <a:defRPr sz="1400">
-                <a:solidFill>
-                  <a:srgbClr val="2D2A26"/>
-                </a:solidFill>
-                <a:latin typeface="Calibri"/>
-              </a:defRPr>
-            </a:pPr>
-            <a:r>
-              <a:t>• Includes 10 Pro seats</a:t>
-            </a:r>
-          </a:p>
-          <a:p>
-            <a:pPr>
-              <a:lnSpc>
-                <a:spcPct val="120000"/>
-              </a:lnSpc>
-              <a:spcAft>
-                <a:spcPts val="1000"/>
-              </a:spcAft>
-              <a:defRPr sz="1400">
-                <a:solidFill>
-                  <a:srgbClr val="2D2A26"/>
-                </a:solidFill>
-                <a:latin typeface="Calibri"/>
-              </a:defRPr>
-            </a:pPr>
-            <a:r>
-              <a:t>• White-glove onboarding</a:t>
-            </a:r>
-          </a:p>
-          <a:p>
-            <a:pPr>
-              <a:lnSpc>
-                <a:spcPct val="120000"/>
-              </a:lnSpc>
-              <a:spcAft>
-                <a:spcPts val="1000"/>
-              </a:spcAft>
-              <a:defRPr sz="1400">
-                <a:solidFill>
-                  <a:srgbClr val="2D2A26"/>
-                </a:solidFill>
-                <a:latin typeface="Calibri"/>
-              </a:defRPr>
-            </a:pPr>
-            <a:r>
-              <a:t>• Custom workflows</a:t>
-            </a:r>
-          </a:p>
-          <a:p>
-            <a:pPr>
-              <a:lnSpc>
-                <a:spcPct val="120000"/>
-              </a:lnSpc>
-              <a:spcAft>
-                <a:spcPts val="1000"/>
-              </a:spcAft>
-              <a:defRPr sz="1400">
-                <a:solidFill>
-                  <a:srgbClr val="2D2A26"/>
-                </a:solidFill>
-                <a:latin typeface="Calibri"/>
-              </a:defRPr>
-            </a:pPr>
-            <a:r>
-              <a:t>• Quarterly reviews</a:t>
-            </a:r>
-          </a:p>
-          <a:p>
-            <a:pPr>
-              <a:lnSpc>
-                <a:spcPct val="120000"/>
-              </a:lnSpc>
-              <a:spcAft>
-                <a:spcPts val="1000"/>
-              </a:spcAft>
-              <a:defRPr sz="1400">
-                <a:solidFill>
-                  <a:srgbClr val="2D2A26"/>
-                </a:solidFill>
-                <a:latin typeface="Calibri"/>
-              </a:defRPr>
-            </a:pPr>
-            <a:r>
-              <a:t>• +£39/extra seat</a:t>
-            </a:r>
-          </a:p>
-        </p:txBody>
-      </p:sp>
-      <p:sp>
-        <p:nvSpPr>
-          <p:cNvPr id="19" name="TextBox 18"/>
           <p:cNvSpPr txBox="1"/>
           <p:nvPr/>
         </p:nvSpPr>
@@ -5346,7 +4429,7 @@
                 </a:solidFill>
                 <a:latin typeface="Georgia"/>
               </a:rPr>
-              <a:t>See your workspace before you commit.</a:t>
+              <a:t>Bring one repeated workflow.</a:t>
             </a:r>
           </a:p>
         </p:txBody>
@@ -5381,7 +4464,7 @@
                 </a:solidFill>
                 <a:latin typeface="Calibri"/>
               </a:rPr>
-              <a:t>Book a 20-minute demo and we’ll build a live workspace around your own documents.</a:t>
+              <a:t>We’ll show you how it fits: a 20-minute demo around a report, bid or return you already produce. No slides, no signup.</a:t>
             </a:r>
           </a:p>
         </p:txBody>
@@ -5416,7 +4499,7 @@
                 </a:solidFill>
                 <a:latin typeface="Calibri"/>
               </a:rPr>
-              <a:t>hello@flowgridos.co.uk · 14-day trial, no card required</a:t>
+              <a:t>clive@platform91.com · or join the pilot list at flowgridos.co.uk</a:t>
             </a:r>
           </a:p>
         </p:txBody>

</xml_diff>

<commit_message>
docs(sales): match the site on data hosting; say what research mode really does
Customer one-pager: drop the 'held in the UK' claim to match the security page, and say the UK GDPR DPA names where data is hosted. Research mode now explains that it reads the pages behind the results and cites each one, rather than reading as a plain web search. Deck bullet updated to match; PDF and both decks regenerated.

Co-Authored-By: Claude Fable 5.1 <noreply@anthropic.com>
</commit_message>
<xml_diff>
--- a/docs/flowgrid-os-customer-deck.pptx
+++ b/docs/flowgrid-os-customer-deck.pptx
@@ -10,7 +10,7 @@
     <p:sldId id="258" r:id="rId9"/>
     <p:sldId id="259" r:id="rId10"/>
     <p:sldId id="260" r:id="rId11"/>
-    <p:sldId id="262" r:id="rId13"/>
+    <p:sldId id="261" r:id="rId12"/>
   </p:sldIdLst>
   <p:sldSz cx="12191695" cy="6858000" type="screen4x3"/>
   <p:notesSz cx="6858000" cy="9144000"/>
@@ -3953,29 +3953,6 @@
               <a:t>• Projects and plans with stages, budgets and risks</a:t>
             </a:r>
           </a:p>
-        </p:txBody>
-      </p:sp>
-      <p:sp>
-        <p:nvSpPr>
-          <p:cNvPr id="5" name="TextBox 4"/>
-          <p:cNvSpPr txBox="1"/>
-          <p:nvPr/>
-        </p:nvSpPr>
-        <p:spPr>
-          <a:xfrm>
-            <a:off x="6278727" y="1371600"/>
-            <a:ext cx="5364327" cy="4937760"/>
-          </a:xfrm>
-          <a:prstGeom prst="rect">
-            <a:avLst/>
-          </a:prstGeom>
-          <a:noFill/>
-        </p:spPr>
-        <p:txBody>
-          <a:bodyPr wrap="square" anchor="t">
-            <a:spAutoFit/>
-          </a:bodyPr>
-          <a:lstStyle/>
           <a:p>
             <a:pPr>
               <a:lnSpc>
@@ -3995,6 +3972,29 @@
               <a:t>• Branded exports: PDF and editable PowerPoint</a:t>
             </a:r>
           </a:p>
+        </p:txBody>
+      </p:sp>
+      <p:sp>
+        <p:nvSpPr>
+          <p:cNvPr id="5" name="TextBox 4"/>
+          <p:cNvSpPr txBox="1"/>
+          <p:nvPr/>
+        </p:nvSpPr>
+        <p:spPr>
+          <a:xfrm>
+            <a:off x="6278727" y="1371600"/>
+            <a:ext cx="5364327" cy="4937760"/>
+          </a:xfrm>
+          <a:prstGeom prst="rect">
+            <a:avLst/>
+          </a:prstGeom>
+          <a:noFill/>
+        </p:spPr>
+        <p:txBody>
+          <a:bodyPr wrap="square" anchor="t">
+            <a:spAutoFit/>
+          </a:bodyPr>
+          <a:lstStyle/>
           <a:p>
             <a:pPr>
               <a:lnSpc>
@@ -4011,7 +4011,7 @@
               </a:defRPr>
             </a:pPr>
             <a:r>
-              <a:t>• Research mode with cited web sources</a:t>
+              <a:t>• Research mode: reads the web pages, not just the links, and cites each source</a:t>
             </a:r>
           </a:p>
           <a:p>
@@ -4346,7 +4346,7 @@
 </p:sld>
 </file>
 
-<file path=ppt/slides/slide7.xml><?xml version="1.0" encoding="utf-8"?>
+<file path=ppt/slides/slide6.xml><?xml version="1.0" encoding="utf-8"?>
 <p:sld xmlns:a="http://schemas.openxmlformats.org/drawingml/2006/main" xmlns:p="http://schemas.openxmlformats.org/presentationml/2006/main" xmlns:r="http://schemas.openxmlformats.org/officeDocument/2006/relationships">
   <p:cSld>
     <p:spTree>

</xml_diff>

<commit_message>
docs(sales): drop 'UK-held data' from the customer deck too
The Privacy & trust slide still asserted UK-held data after the site and one-pager withdrew the claim. Now matches: zero-data-retention hosting, and a DPA that names where data is hosted. Decks regenerated.

Co-Authored-By: Claude Fable 5.1 <noreply@anthropic.com>
</commit_message>
<xml_diff>
--- a/docs/flowgrid-os-customer-deck.pptx
+++ b/docs/flowgrid-os-customer-deck.pptx
@@ -4260,7 +4260,7 @@
               </a:defRPr>
             </a:pPr>
             <a:r>
-              <a:t>• UK-held data. Zero-data-retention hosting by default; your documents are not used to train anyone’s models.</a:t>
+              <a:t>• Zero-data-retention hosting by default; your documents are not used to train anyone’s models.</a:t>
             </a:r>
           </a:p>
           <a:p>
@@ -4279,7 +4279,7 @@
               </a:defRPr>
             </a:pPr>
             <a:r>
-              <a:t>• UK GDPR, with a Data Processing Agreement as part of your terms, plus standard-format export and agreed return and deletion.</a:t>
+              <a:t>• UK GDPR, with a Data Processing Agreement that names where your data is hosted, plus standard-format export and agreed return and deletion.</a:t>
             </a:r>
           </a:p>
           <a:p>

</xml_diff>

<commit_message>
docs(sales): one-pagers and decks use the plain names and the project model
- Customer, partner, Groundwork and Grantwork one-pagers: "documents"
  for "vault"; module cards headed "Groundwork · Development projects" and
  "Grantwork · Grant funding"; every project described as chat, documents
  and a plan of owned tasks; Contacts and grant applications as tabs on
  any project. The partner "Who it's for" line now describes partners
  rather than repeating the customer wording.
- All four PDFs re-rendered with headless Chrome (one page each, web
  fonts loaded).
- Decks regenerated: same wording, and the customer deck gains a
  "Built for your sector" slide it previously lacked.

Co-Authored-By: Claude Fable 5.1 <noreply@anthropic.com>
</commit_message>
<xml_diff>
--- a/docs/flowgrid-os-customer-deck.pptx
+++ b/docs/flowgrid-os-customer-deck.pptx
@@ -11,6 +11,7 @@
     <p:sldId id="259" r:id="rId10"/>
     <p:sldId id="260" r:id="rId11"/>
     <p:sldId id="261" r:id="rId12"/>
+    <p:sldId id="262" r:id="rId13"/>
   </p:sldIdLst>
   <p:sldSz cx="12191695" cy="6858000" type="screen4x3"/>
   <p:notesSz cx="6858000" cy="9144000"/>
@@ -3682,7 +3683,7 @@
               </a:defRPr>
             </a:pPr>
             <a:r>
-              <a:t>• Answers cite the document and page, and say so plainly when the vault has nothing.</a:t>
+              <a:t>• Answers cite the document and page, and say so plainly when your documents don't hold the answer.</a:t>
             </a:r>
           </a:p>
           <a:p>
@@ -3701,7 +3702,26 @@
               </a:defRPr>
             </a:pPr>
             <a:r>
-              <a:t>• Confirm a fact once and every draft reuses it; projects carry stages, budgets and risks.</a:t>
+              <a:t>• Confirm a fact once and every draft reuses it.</a:t>
+            </a:r>
+          </a:p>
+          <a:p>
+            <a:pPr>
+              <a:lnSpc>
+                <a:spcPct val="120000"/>
+              </a:lnSpc>
+              <a:spcAft>
+                <a:spcPts val="1000"/>
+              </a:spcAft>
+              <a:defRPr sz="2200">
+                <a:solidFill>
+                  <a:srgbClr val="2D2A26"/>
+                </a:solidFill>
+                <a:latin typeface="Calibri"/>
+              </a:defRPr>
+            </a:pPr>
+            <a:r>
+              <a:t>• Every project comes with scoped chat, its documents and a plan of owned tasks; modules add stage gates, budgets and risks, or grant records.</a:t>
             </a:r>
           </a:p>
           <a:p>
@@ -3912,7 +3932,7 @@
               </a:defRPr>
             </a:pPr>
             <a:r>
-              <a:t>• Document vault (PDF, Word, Excel), searchable</a:t>
+              <a:t>• Documents (PDF, Word, Excel), searchable</a:t>
             </a:r>
           </a:p>
           <a:p>
@@ -3950,7 +3970,7 @@
               </a:defRPr>
             </a:pPr>
             <a:r>
-              <a:t>• Projects and plans with stages, budgets and risks</a:t>
+              <a:t>• Projects and plans: chat, documents and owned tasks on every project</a:t>
             </a:r>
           </a:p>
           <a:p>
@@ -4030,7 +4050,7 @@
               </a:defRPr>
             </a:pPr>
             <a:r>
-              <a:t>• Contact book with spreadsheet import</a:t>
+              <a:t>• Contacts with spreadsheet import, as a tab on any project</a:t>
             </a:r>
           </a:p>
           <a:p>
@@ -4199,7 +4219,7 @@
                 </a:solidFill>
                 <a:latin typeface="Georgia"/>
               </a:rPr>
-              <a:t>Privacy &amp; trust</a:t>
+              <a:t>Built for your sector</a:t>
             </a:r>
           </a:p>
         </p:txBody>
@@ -4241,7 +4261,7 @@
               </a:defRPr>
             </a:pPr>
             <a:r>
-              <a:t>• Your workspace is isolated from every other customer at the database level, not only by application code.</a:t>
+              <a:t>• The core platform (documents, confirmed facts and projects) is always included.</a:t>
             </a:r>
           </a:p>
           <a:p>
@@ -4260,7 +4280,7 @@
               </a:defRPr>
             </a:pPr>
             <a:r>
-              <a:t>• Zero-data-retention hosting by default; your documents are not used to train anyone’s models.</a:t>
+              <a:t>• Switch on a module and projects gain what your sector needs.</a:t>
             </a:r>
           </a:p>
           <a:p>
@@ -4279,7 +4299,7 @@
               </a:defRPr>
             </a:pPr>
             <a:r>
-              <a:t>• UK GDPR, with a Data Processing Agreement that names where your data is hosted, plus standard-format export and agreed return and deletion.</a:t>
+              <a:t>• Groundwork · Development projects: stage gates, funding, budget, risk and planning records, with client reports drafted from live records. Available in pilot.</a:t>
             </a:r>
           </a:p>
           <a:p>
@@ -4298,7 +4318,26 @@
               </a:defRPr>
             </a:pPr>
             <a:r>
-              <a:t>• Every AI call is recorded with usage and cost, and spending limits keep invoices predictable.</a:t>
+              <a:t>• Grantwork · Grant funding: applications, award conditions, impact evidence and monitoring returns, as a tab on any project. Available in pilot.</a:t>
+            </a:r>
+          </a:p>
+          <a:p>
+            <a:pPr>
+              <a:lnSpc>
+                <a:spcPct val="120000"/>
+              </a:lnSpc>
+              <a:spcAft>
+                <a:spcPts val="1000"/>
+              </a:spcAft>
+              <a:defRPr sz="2200">
+                <a:solidFill>
+                  <a:srgbClr val="2D2A26"/>
+                </a:solidFill>
+                <a:latin typeface="Calibri"/>
+              </a:defRPr>
+            </a:pPr>
+            <a:r>
+              <a:t>• Contacts: organisations and people linked to any project.</a:t>
             </a:r>
           </a:p>
         </p:txBody>
@@ -4347,6 +4386,236 @@
 </file>
 
 <file path=ppt/slides/slide6.xml><?xml version="1.0" encoding="utf-8"?>
+<p:sld xmlns:a="http://schemas.openxmlformats.org/drawingml/2006/main" xmlns:p="http://schemas.openxmlformats.org/presentationml/2006/main" xmlns:r="http://schemas.openxmlformats.org/officeDocument/2006/relationships">
+  <p:cSld>
+    <p:spTree>
+      <p:nvGrpSpPr>
+        <p:cNvPr id="1" name=""/>
+        <p:cNvGrpSpPr/>
+        <p:nvPr/>
+      </p:nvGrpSpPr>
+      <p:grpSpPr/>
+      <p:sp>
+        <p:nvSpPr>
+          <p:cNvPr id="2" name="Rectangle 1"/>
+          <p:cNvSpPr/>
+          <p:nvPr/>
+        </p:nvSpPr>
+        <p:spPr>
+          <a:xfrm>
+            <a:off x="0" y="0"/>
+            <a:ext cx="12191695" cy="1005840"/>
+          </a:xfrm>
+          <a:prstGeom prst="rect">
+            <a:avLst/>
+          </a:prstGeom>
+          <a:solidFill>
+            <a:srgbClr val="B14E2E"/>
+          </a:solidFill>
+          <a:ln>
+            <a:noFill/>
+          </a:ln>
+        </p:spPr>
+        <p:style>
+          <a:lnRef idx="1">
+            <a:schemeClr val="accent1"/>
+          </a:lnRef>
+          <a:fillRef idx="3">
+            <a:schemeClr val="accent1"/>
+          </a:fillRef>
+          <a:effectRef idx="2">
+            <a:schemeClr val="accent1"/>
+          </a:effectRef>
+          <a:fontRef idx="minor">
+            <a:schemeClr val="lt1"/>
+          </a:fontRef>
+        </p:style>
+        <p:txBody>
+          <a:bodyPr rtlCol="0" anchor="ctr"/>
+          <a:lstStyle/>
+          <a:p>
+            <a:pPr algn="ctr"/>
+          </a:p>
+        </p:txBody>
+      </p:sp>
+      <p:sp>
+        <p:nvSpPr>
+          <p:cNvPr id="3" name="TextBox 2"/>
+          <p:cNvSpPr txBox="1"/>
+          <p:nvPr/>
+        </p:nvSpPr>
+        <p:spPr>
+          <a:xfrm>
+            <a:off x="548640" y="201168"/>
+            <a:ext cx="11094415" cy="731520"/>
+          </a:xfrm>
+          <a:prstGeom prst="rect">
+            <a:avLst/>
+          </a:prstGeom>
+          <a:noFill/>
+        </p:spPr>
+        <p:txBody>
+          <a:bodyPr wrap="square">
+            <a:spAutoFit/>
+          </a:bodyPr>
+          <a:lstStyle/>
+          <a:p>
+            <a:pPr algn="l"/>
+            <a:r>
+              <a:rPr sz="3400" b="1">
+                <a:solidFill>
+                  <a:srgbClr val="FFFFFF"/>
+                </a:solidFill>
+                <a:latin typeface="Georgia"/>
+              </a:rPr>
+              <a:t>Privacy &amp; trust</a:t>
+            </a:r>
+          </a:p>
+        </p:txBody>
+      </p:sp>
+      <p:sp>
+        <p:nvSpPr>
+          <p:cNvPr id="4" name="TextBox 3"/>
+          <p:cNvSpPr txBox="1"/>
+          <p:nvPr/>
+        </p:nvSpPr>
+        <p:spPr>
+          <a:xfrm>
+            <a:off x="548640" y="1325880"/>
+            <a:ext cx="11094415" cy="5120640"/>
+          </a:xfrm>
+          <a:prstGeom prst="rect">
+            <a:avLst/>
+          </a:prstGeom>
+          <a:noFill/>
+        </p:spPr>
+        <p:txBody>
+          <a:bodyPr wrap="square" anchor="t">
+            <a:spAutoFit/>
+          </a:bodyPr>
+          <a:lstStyle/>
+          <a:p>
+            <a:pPr>
+              <a:lnSpc>
+                <a:spcPct val="120000"/>
+              </a:lnSpc>
+              <a:spcAft>
+                <a:spcPts val="1000"/>
+              </a:spcAft>
+              <a:defRPr sz="2200">
+                <a:solidFill>
+                  <a:srgbClr val="2D2A26"/>
+                </a:solidFill>
+                <a:latin typeface="Calibri"/>
+              </a:defRPr>
+            </a:pPr>
+            <a:r>
+              <a:t>• Your workspace is isolated from every other customer at the database level, not only by application code.</a:t>
+            </a:r>
+          </a:p>
+          <a:p>
+            <a:pPr>
+              <a:lnSpc>
+                <a:spcPct val="120000"/>
+              </a:lnSpc>
+              <a:spcAft>
+                <a:spcPts val="1000"/>
+              </a:spcAft>
+              <a:defRPr sz="2200">
+                <a:solidFill>
+                  <a:srgbClr val="2D2A26"/>
+                </a:solidFill>
+                <a:latin typeface="Calibri"/>
+              </a:defRPr>
+            </a:pPr>
+            <a:r>
+              <a:t>• Zero-data-retention hosting by default; your documents are not used to train anyone’s models.</a:t>
+            </a:r>
+          </a:p>
+          <a:p>
+            <a:pPr>
+              <a:lnSpc>
+                <a:spcPct val="120000"/>
+              </a:lnSpc>
+              <a:spcAft>
+                <a:spcPts val="1000"/>
+              </a:spcAft>
+              <a:defRPr sz="2200">
+                <a:solidFill>
+                  <a:srgbClr val="2D2A26"/>
+                </a:solidFill>
+                <a:latin typeface="Calibri"/>
+              </a:defRPr>
+            </a:pPr>
+            <a:r>
+              <a:t>• UK GDPR, with a Data Processing Agreement that names where your data is hosted, plus standard-format export and agreed return and deletion.</a:t>
+            </a:r>
+          </a:p>
+          <a:p>
+            <a:pPr>
+              <a:lnSpc>
+                <a:spcPct val="120000"/>
+              </a:lnSpc>
+              <a:spcAft>
+                <a:spcPts val="1000"/>
+              </a:spcAft>
+              <a:defRPr sz="2200">
+                <a:solidFill>
+                  <a:srgbClr val="2D2A26"/>
+                </a:solidFill>
+                <a:latin typeface="Calibri"/>
+              </a:defRPr>
+            </a:pPr>
+            <a:r>
+              <a:t>• Every AI call is recorded with usage and cost, and spending limits keep invoices predictable.</a:t>
+            </a:r>
+          </a:p>
+        </p:txBody>
+      </p:sp>
+      <p:sp>
+        <p:nvSpPr>
+          <p:cNvPr id="5" name="TextBox 4"/>
+          <p:cNvSpPr txBox="1"/>
+          <p:nvPr/>
+        </p:nvSpPr>
+        <p:spPr>
+          <a:xfrm>
+            <a:off x="548640" y="6537960"/>
+            <a:ext cx="11094415" cy="228600"/>
+          </a:xfrm>
+          <a:prstGeom prst="rect">
+            <a:avLst/>
+          </a:prstGeom>
+          <a:noFill/>
+        </p:spPr>
+        <p:txBody>
+          <a:bodyPr wrap="square">
+            <a:spAutoFit/>
+          </a:bodyPr>
+          <a:lstStyle/>
+          <a:p>
+            <a:pPr algn="r"/>
+            <a:r>
+              <a:rPr sz="1000" b="0">
+                <a:solidFill>
+                  <a:srgbClr val="5B5752"/>
+                </a:solidFill>
+                <a:latin typeface="Calibri"/>
+              </a:rPr>
+              <a:t>flowgridos.co.uk</a:t>
+            </a:r>
+          </a:p>
+        </p:txBody>
+      </p:sp>
+    </p:spTree>
+  </p:cSld>
+  <p:clrMapOvr>
+    <a:masterClrMapping/>
+  </p:clrMapOvr>
+</p:sld>
+</file>
+
+<file path=ppt/slides/slide7.xml><?xml version="1.0" encoding="utf-8"?>
 <p:sld xmlns:a="http://schemas.openxmlformats.org/drawingml/2006/main" xmlns:p="http://schemas.openxmlformats.org/presentationml/2006/main" xmlns:r="http://schemas.openxmlformats.org/officeDocument/2006/relationships">
   <p:cSld>
     <p:spTree>

</xml_diff>

<commit_message>
fix(marketing): the plan is optional; partners are the subject
Review comments on #16:
- A general project has chat and documents with an optional plan of
  tasks (kinds.py), so every copy of the sentence now says "an optional
  plan of owned tasks" rather than promising one. PDFs and decks
  regenerated.
- Partner one-pager "Who it's for" makes agencies, MSPs and consultancies
  the subject of the sentence.

Co-Authored-By: Claude Fable 5.1 <noreply@anthropic.com>
</commit_message>
<xml_diff>
--- a/docs/flowgrid-os-customer-deck.pptx
+++ b/docs/flowgrid-os-customer-deck.pptx
@@ -3721,7 +3721,7 @@
               </a:defRPr>
             </a:pPr>
             <a:r>
-              <a:t>• Every project comes with scoped chat, its documents and a plan of owned tasks; modules add stage gates, budgets and risks, or grant records.</a:t>
+              <a:t>• Every project comes with scoped chat, its documents and an optional plan of owned tasks; modules add stage gates, budgets and risks, or grant records.</a:t>
             </a:r>
           </a:p>
           <a:p>
@@ -3970,7 +3970,7 @@
               </a:defRPr>
             </a:pPr>
             <a:r>
-              <a:t>• Projects and plans: chat, documents and owned tasks on every project</a:t>
+              <a:t>• Projects and plans: chat and documents on every project, with an optional plan of owned tasks</a:t>
             </a:r>
           </a:p>
           <a:p>

</xml_diff>